<commit_message>
Présentation : Trusted Advisor dans la slide des coûts, 23 services
Co-Authored-By: Claude Opus 5.5 <noreply@anthropic.com>
Claude-Session: https://claude.ai/code/session_01HkLVaLgJdp27NZiEn5ew9a
</commit_message>
<xml_diff>
--- a/docs/SHOP-IMT-presentation.pptx
+++ b/docs/SHOP-IMT-presentation.pptx
@@ -664,6 +664,11 @@
           </a:p>
           <a:p>
             <a:r>
+              <a:t>Trusted Advisor surveille aussi le compte gratuitement : dès qu'un contrôle passe à l'orange ou au rouge, EventBridge nous l'envoie par e-mail.</a:t>
+            </a:r>
+          </a:p>
+          <a:p>
+            <a:r>
               <a:t>Transition : « Gabin, et la commande du jury ? »</a:t>
             </a:r>
           </a:p>
@@ -770,7 +775,7 @@
           </a:p>
           <a:p>
             <a:r>
-              <a:t>Services (22) : CloudFront, S3, API Gateway, Lambda, DynamoDB, SNS, SQS, Step Functions, SES, Cognito, Translate, EventBridge Scheduler, CloudWatch, CloudTrail, IAM, SSM, Budgets, et pour la solution EC2 : EC2, Auto Scaling, Elastic Load Balancing, RDS, VPC.</a:t>
+              <a:t>Services (23) : CloudFront, S3, API Gateway, Lambda, DynamoDB, SNS, SQS, Step Functions, SES, Cognito, Translate, EventBridge Scheduler, CloudWatch, CloudTrail, IAM, SSM, Budgets, Trusted Advisor, et pour la solution EC2 : EC2, Auto Scaling, Elastic Load Balancing, RDS, VPC.</a:t>
             </a:r>
           </a:p>
         </p:txBody>
@@ -5014,6 +5019,119 @@
                   </a:tcPr>
                 </a:tc>
               </a:tr>
+              <a:tr h="548640">
+                <a:tc>
+                  <a:txBody>
+                    <a:bodyPr/>
+                    <a:lstStyle/>
+                    <a:p>
+                      <a:pPr indent="0" marL="0">
+                        <a:buNone/>
+                      </a:pPr>
+                      <a:r>
+                        <a:rPr lang="en-US" sz="1300" dirty="0">
+                          <a:solidFill>
+                            <a:schemeClr val="tx1"/>
+                          </a:solidFill>
+                        </a:rPr>
+                        <a:t>Trusted Advisor</a:t>
+                      </a:r>
+                      <a:endParaRPr lang="en-US" sz="1300" dirty="0"/>
+                    </a:p>
+                  </a:txBody>
+                  <a:tcPr marL="109728" marR="109728" marT="0" marB="0" anchor="ctr">
+                    <a:lnL w="0" cap="flat" cmpd="sng" algn="ctr">
+                      <a:noFill/>
+                    </a:lnL>
+                    <a:lnR w="0" cap="flat" cmpd="sng" algn="ctr">
+                      <a:noFill/>
+                    </a:lnR>
+                    <a:lnT w="0" cap="flat" cmpd="sng" algn="ctr">
+                      <a:noFill/>
+                    </a:lnT>
+                    <a:lnB w="0" cap="flat" cmpd="sng" algn="ctr">
+                      <a:noFill/>
+                    </a:lnB>
+                    <a:solidFill>
+                      <a:schemeClr val="bg2"/>
+                    </a:solidFill>
+                  </a:tcPr>
+                </a:tc>
+                <a:tc>
+                  <a:txBody>
+                    <a:bodyPr/>
+                    <a:lstStyle/>
+                    <a:p>
+                      <a:pPr indent="0" marL="0">
+                        <a:buNone/>
+                      </a:pPr>
+                      <a:r>
+                        <a:rPr lang="en-US" sz="1300" dirty="0">
+                          <a:solidFill>
+                            <a:schemeClr val="tx1"/>
+                          </a:solidFill>
+                        </a:rPr>
+                        <a:t>Contrôles de base, alertes EventBridge</a:t>
+                      </a:r>
+                      <a:endParaRPr lang="en-US" sz="1300" dirty="0"/>
+                    </a:p>
+                  </a:txBody>
+                  <a:tcPr marL="109728" marR="109728" marT="0" marB="0" anchor="ctr">
+                    <a:lnL w="0" cap="flat" cmpd="sng" algn="ctr">
+                      <a:noFill/>
+                    </a:lnL>
+                    <a:lnR w="0" cap="flat" cmpd="sng" algn="ctr">
+                      <a:noFill/>
+                    </a:lnR>
+                    <a:lnT w="0" cap="flat" cmpd="sng" algn="ctr">
+                      <a:noFill/>
+                    </a:lnT>
+                    <a:lnB w="0" cap="flat" cmpd="sng" algn="ctr">
+                      <a:noFill/>
+                    </a:lnB>
+                    <a:solidFill>
+                      <a:schemeClr val="bg2"/>
+                    </a:solidFill>
+                  </a:tcPr>
+                </a:tc>
+                <a:tc>
+                  <a:txBody>
+                    <a:bodyPr/>
+                    <a:lstStyle/>
+                    <a:p>
+                      <a:pPr indent="0" marL="0">
+                        <a:buNone/>
+                      </a:pPr>
+                      <a:r>
+                        <a:rPr lang="en-US" sz="1300" dirty="0">
+                          <a:solidFill>
+                            <a:schemeClr val="tx1"/>
+                          </a:solidFill>
+                        </a:rPr>
+                        <a:t>Inclus dans le support Basic</a:t>
+                      </a:r>
+                      <a:endParaRPr lang="en-US" sz="1300" dirty="0"/>
+                    </a:p>
+                  </a:txBody>
+                  <a:tcPr marL="109728" marR="109728" marT="0" marB="0" anchor="ctr">
+                    <a:lnL w="0" cap="flat" cmpd="sng" algn="ctr">
+                      <a:noFill/>
+                    </a:lnL>
+                    <a:lnR w="0" cap="flat" cmpd="sng" algn="ctr">
+                      <a:noFill/>
+                    </a:lnR>
+                    <a:lnT w="0" cap="flat" cmpd="sng" algn="ctr">
+                      <a:noFill/>
+                    </a:lnT>
+                    <a:lnB w="0" cap="flat" cmpd="sng" algn="ctr">
+                      <a:noFill/>
+                    </a:lnB>
+                    <a:solidFill>
+                      <a:schemeClr val="bg2"/>
+                    </a:solidFill>
+                  </a:tcPr>
+                </a:tc>
+              </a:tr>
             </a:tbl>
           </a:graphicData>
         </a:graphic>
@@ -6577,7 +6695,7 @@
                   <a:schemeClr val="accent1"/>
                 </a:solidFill>
               </a:rPr>
-              <a:t>22</a:t>
+              <a:t>23</a:t>
             </a:r>
             <a:endParaRPr lang="en-US" sz="5400" dirty="0"/>
           </a:p>

</xml_diff>

<commit_message>
Revert "Présentation : Trusted Advisor dans la slide des coûts, 23 services"
This reverts commit 70ae869913e64f09d5e7d6d80c455c5a3954584f.
</commit_message>
<xml_diff>
--- a/docs/SHOP-IMT-presentation.pptx
+++ b/docs/SHOP-IMT-presentation.pptx
@@ -664,11 +664,6 @@
           </a:p>
           <a:p>
             <a:r>
-              <a:t>Trusted Advisor surveille aussi le compte gratuitement : dès qu'un contrôle passe à l'orange ou au rouge, EventBridge nous l'envoie par e-mail.</a:t>
-            </a:r>
-          </a:p>
-          <a:p>
-            <a:r>
               <a:t>Transition : « Gabin, et la commande du jury ? »</a:t>
             </a:r>
           </a:p>
@@ -775,7 +770,7 @@
           </a:p>
           <a:p>
             <a:r>
-              <a:t>Services (23) : CloudFront, S3, API Gateway, Lambda, DynamoDB, SNS, SQS, Step Functions, SES, Cognito, Translate, EventBridge Scheduler, CloudWatch, CloudTrail, IAM, SSM, Budgets, Trusted Advisor, et pour la solution EC2 : EC2, Auto Scaling, Elastic Load Balancing, RDS, VPC.</a:t>
+              <a:t>Services (22) : CloudFront, S3, API Gateway, Lambda, DynamoDB, SNS, SQS, Step Functions, SES, Cognito, Translate, EventBridge Scheduler, CloudWatch, CloudTrail, IAM, SSM, Budgets, et pour la solution EC2 : EC2, Auto Scaling, Elastic Load Balancing, RDS, VPC.</a:t>
             </a:r>
           </a:p>
         </p:txBody>
@@ -5019,119 +5014,6 @@
                   </a:tcPr>
                 </a:tc>
               </a:tr>
-              <a:tr h="548640">
-                <a:tc>
-                  <a:txBody>
-                    <a:bodyPr/>
-                    <a:lstStyle/>
-                    <a:p>
-                      <a:pPr indent="0" marL="0">
-                        <a:buNone/>
-                      </a:pPr>
-                      <a:r>
-                        <a:rPr lang="en-US" sz="1300" dirty="0">
-                          <a:solidFill>
-                            <a:schemeClr val="tx1"/>
-                          </a:solidFill>
-                        </a:rPr>
-                        <a:t>Trusted Advisor</a:t>
-                      </a:r>
-                      <a:endParaRPr lang="en-US" sz="1300" dirty="0"/>
-                    </a:p>
-                  </a:txBody>
-                  <a:tcPr marL="109728" marR="109728" marT="0" marB="0" anchor="ctr">
-                    <a:lnL w="0" cap="flat" cmpd="sng" algn="ctr">
-                      <a:noFill/>
-                    </a:lnL>
-                    <a:lnR w="0" cap="flat" cmpd="sng" algn="ctr">
-                      <a:noFill/>
-                    </a:lnR>
-                    <a:lnT w="0" cap="flat" cmpd="sng" algn="ctr">
-                      <a:noFill/>
-                    </a:lnT>
-                    <a:lnB w="0" cap="flat" cmpd="sng" algn="ctr">
-                      <a:noFill/>
-                    </a:lnB>
-                    <a:solidFill>
-                      <a:schemeClr val="bg2"/>
-                    </a:solidFill>
-                  </a:tcPr>
-                </a:tc>
-                <a:tc>
-                  <a:txBody>
-                    <a:bodyPr/>
-                    <a:lstStyle/>
-                    <a:p>
-                      <a:pPr indent="0" marL="0">
-                        <a:buNone/>
-                      </a:pPr>
-                      <a:r>
-                        <a:rPr lang="en-US" sz="1300" dirty="0">
-                          <a:solidFill>
-                            <a:schemeClr val="tx1"/>
-                          </a:solidFill>
-                        </a:rPr>
-                        <a:t>Contrôles de base, alertes EventBridge</a:t>
-                      </a:r>
-                      <a:endParaRPr lang="en-US" sz="1300" dirty="0"/>
-                    </a:p>
-                  </a:txBody>
-                  <a:tcPr marL="109728" marR="109728" marT="0" marB="0" anchor="ctr">
-                    <a:lnL w="0" cap="flat" cmpd="sng" algn="ctr">
-                      <a:noFill/>
-                    </a:lnL>
-                    <a:lnR w="0" cap="flat" cmpd="sng" algn="ctr">
-                      <a:noFill/>
-                    </a:lnR>
-                    <a:lnT w="0" cap="flat" cmpd="sng" algn="ctr">
-                      <a:noFill/>
-                    </a:lnT>
-                    <a:lnB w="0" cap="flat" cmpd="sng" algn="ctr">
-                      <a:noFill/>
-                    </a:lnB>
-                    <a:solidFill>
-                      <a:schemeClr val="bg2"/>
-                    </a:solidFill>
-                  </a:tcPr>
-                </a:tc>
-                <a:tc>
-                  <a:txBody>
-                    <a:bodyPr/>
-                    <a:lstStyle/>
-                    <a:p>
-                      <a:pPr indent="0" marL="0">
-                        <a:buNone/>
-                      </a:pPr>
-                      <a:r>
-                        <a:rPr lang="en-US" sz="1300" dirty="0">
-                          <a:solidFill>
-                            <a:schemeClr val="tx1"/>
-                          </a:solidFill>
-                        </a:rPr>
-                        <a:t>Inclus dans le support Basic</a:t>
-                      </a:r>
-                      <a:endParaRPr lang="en-US" sz="1300" dirty="0"/>
-                    </a:p>
-                  </a:txBody>
-                  <a:tcPr marL="109728" marR="109728" marT="0" marB="0" anchor="ctr">
-                    <a:lnL w="0" cap="flat" cmpd="sng" algn="ctr">
-                      <a:noFill/>
-                    </a:lnL>
-                    <a:lnR w="0" cap="flat" cmpd="sng" algn="ctr">
-                      <a:noFill/>
-                    </a:lnR>
-                    <a:lnT w="0" cap="flat" cmpd="sng" algn="ctr">
-                      <a:noFill/>
-                    </a:lnT>
-                    <a:lnB w="0" cap="flat" cmpd="sng" algn="ctr">
-                      <a:noFill/>
-                    </a:lnB>
-                    <a:solidFill>
-                      <a:schemeClr val="bg2"/>
-                    </a:solidFill>
-                  </a:tcPr>
-                </a:tc>
-              </a:tr>
             </a:tbl>
           </a:graphicData>
         </a:graphic>
@@ -6695,7 +6577,7 @@
                   <a:schemeClr val="accent1"/>
                 </a:solidFill>
               </a:rPr>
-              <a:t>23</a:t>
+              <a:t>22</a:t>
             </a:r>
             <a:endParaRPr lang="en-US" sz="5400" dirty="0"/>
           </a:p>

</xml_diff>